<commit_message>
Align page and PPTX stories: 6 unified steps, no exercise/task/premium labels
Co-authored-by: Copilot <223556219+Copilot@users.noreply.github.com>
</commit_message>
<xml_diff>
--- a/files/Contoso_Active_Story.pptx
+++ b/files/Contoso_Active_Story.pptx
@@ -3519,7 +3519,7 @@
                   <a:srgbClr val="6B7280"/>
                 </a:solidFill>
               </a:rPr>
-              <a:t>Research market + summarise emails &amp; Teams</a:t>
+              <a:t>Get the lay of the land — research Q1 sportswear trends, summarise emails &amp; Teams</a:t>
             </a:r>
           </a:p>
         </p:txBody>
@@ -3647,7 +3647,7 @@
                   <a:srgbClr val="6B7280"/>
                 </a:solidFill>
               </a:rPr>
-              <a:t>Draft the Store Action Plan memo</a:t>
+              <a:t>Draft the action plan — expand the seed memo into a SMART Store Action Plan</a:t>
             </a:r>
           </a:p>
         </p:txBody>
@@ -3775,7 +3775,7 @@
                   <a:srgbClr val="6B7280"/>
                 </a:solidFill>
               </a:rPr>
-              <a:t>Turn the memo into a COO briefing deck</a:t>
+              <a:t>Build the COO deck — turn the memo into a 5-slide briefing</a:t>
             </a:r>
           </a:p>
         </p:txBody>
@@ -3903,7 +3903,7 @@
                   <a:srgbClr val="6B7280"/>
                 </a:solidFill>
               </a:rPr>
-              <a:t>Analyse the March DSR — anomalies, MTD, YoY</a:t>
+              <a:t>Analyse the DSR — MTD vs target, YoY, anomalies, traffic-light formatting in-grid</a:t>
             </a:r>
           </a:p>
         </p:txBody>
@@ -4013,7 +4013,7 @@
                   <a:srgbClr val="1F2937"/>
                 </a:solidFill>
               </a:rPr>
-              <a:t>Cowork · Researcher · Analyst · Image · Pages</a:t>
+              <a:t>Researcher · Analyst · Plan in Excel · Image · Pages</a:t>
             </a:r>
             <a:r>
               <a:rPr sz="900" b="1">
@@ -4021,7 +4021,7 @@
                   <a:srgbClr val="E25522"/>
                 </a:solidFill>
               </a:rPr>
-              <a:t>    Premium</a:t>
+              <a:t/>
             </a:r>
           </a:p>
           <a:p>
@@ -4031,7 +4031,7 @@
                   <a:srgbClr val="6B7280"/>
                 </a:solidFill>
               </a:rPr>
-              <a:t>Forecast Q2, build dashboard sheet, hero visual, share Page</a:t>
+              <a:t>Benchmark Jakarta, forecast Q2, simulate +5% conversion, hero visual, share via Pages</a:t>
             </a:r>
           </a:p>
         </p:txBody>
@@ -4141,7 +4141,7 @@
                   <a:srgbClr val="1F2937"/>
                 </a:solidFill>
               </a:rPr>
-              <a:t>Cowork — HTML dashboard</a:t>
+              <a:t>Cowork</a:t>
             </a:r>
             <a:r>
               <a:rPr sz="900" b="1">
@@ -4149,7 +4149,7 @@
                   <a:srgbClr val="E25522"/>
                 </a:solidFill>
               </a:rPr>
-              <a:t>    Premium</a:t>
+              <a:t/>
             </a:r>
           </a:p>
           <a:p>
@@ -4159,7 +4159,7 @@
                   <a:srgbClr val="6B7280"/>
                 </a:solidFill>
               </a:rPr>
-              <a:t>Generate a live exec dashboard from the DSR</a:t>
+              <a:t>Ship a live HTML dashboard from the DSR — KPI tiles, charts, auto-Key Insights</a:t>
             </a:r>
           </a:p>
         </p:txBody>
@@ -4237,7 +4237,7 @@
                   <a:srgbClr val="1F2937"/>
                 </a:solidFill>
               </a:rPr>
-              <a:t>Microsoft 365 Copilot · Basic (included) + Premium (Cowork, Researcher, Analyst, Plan in Excel)</a:t>
+              <a:t>Microsoft 365 Copilot · Basic (Chat, Word, PowerPoint, Excel) + Premium (Researcher, Analyst, Plan in Excel, Image, Pages, Cowork)</a:t>
             </a:r>
           </a:p>
         </p:txBody>

</xml_diff>

<commit_message>
Tighten flow to 6 focused steps; add Agent Builder card; sync PPTX
Co-authored-by: Copilot <223556219+Copilot@users.noreply.github.com>
</commit_message>
<xml_diff>
--- a/files/Contoso_Active_Story.pptx
+++ b/files/Contoso_Active_Story.pptx
@@ -3564,6 +3564,19 @@
           <a:lstStyle/>
           <a:p>
             <a:pPr algn="ctr"/>
+            <a:r>
+              <a:t>Copilot Chat    Basic</a:t>
+            </a:r>
+          </a:p>
+          <a:p>
+            <a:r>
+              <a:rPr sz="1050">
+                <a:solidFill>
+                  <a:srgbClr val="6B7280"/>
+                </a:solidFill>
+              </a:rPr>
+              <a:t>Get the lay of the land — research Q1 sportswear trends, summarise emails &amp; Teams</a:t>
+            </a:r>
           </a:p>
         </p:txBody>
       </p:sp>
@@ -3629,7 +3642,7 @@
                   <a:srgbClr val="1F2937"/>
                 </a:solidFill>
               </a:rPr>
-              <a:t>Word Agent</a:t>
+              <a:t>WXP · Edit with Copilot    Basic</a:t>
             </a:r>
             <a:r>
               <a:rPr sz="900" b="1">
@@ -3637,7 +3650,7 @@
                   <a:srgbClr val="6B7280"/>
                 </a:solidFill>
               </a:rPr>
-              <a:t>    Basic</a:t>
+              <a:t/>
             </a:r>
           </a:p>
           <a:p>
@@ -3647,7 +3660,7 @@
                   <a:srgbClr val="6B7280"/>
                 </a:solidFill>
               </a:rPr>
-              <a:t>Draft the action plan — expand the seed memo into a SMART Store Action Plan</a:t>
+              <a:t>Edit the DSR, draft the Store Action Plan, build the COO deck</a:t>
             </a:r>
           </a:p>
         </p:txBody>
@@ -3757,7 +3770,7 @@
                   <a:srgbClr val="1F2937"/>
                 </a:solidFill>
               </a:rPr>
-              <a:t>PowerPoint Agent</a:t>
+              <a:t>Researcher    Premium</a:t>
             </a:r>
             <a:r>
               <a:rPr sz="900" b="1">
@@ -3765,7 +3778,7 @@
                   <a:srgbClr val="6B7280"/>
                 </a:solidFill>
               </a:rPr>
-              <a:t>    Basic</a:t>
+              <a:t/>
             </a:r>
           </a:p>
           <a:p>
@@ -3775,7 +3788,7 @@
                   <a:srgbClr val="6B7280"/>
                 </a:solidFill>
               </a:rPr>
-              <a:t>Build the COO deck — turn the memo into a 5-slide briefing</a:t>
+              <a:t>Benchmark Jakarta flagships — Nike, Adidas, Decathlon with citations</a:t>
             </a:r>
           </a:p>
         </p:txBody>
@@ -3885,7 +3898,7 @@
                   <a:srgbClr val="1F2937"/>
                 </a:solidFill>
               </a:rPr>
-              <a:t>Excel Agent</a:t>
+              <a:t>Analyst · DSR    Premium</a:t>
             </a:r>
             <a:r>
               <a:rPr sz="900" b="1">
@@ -3893,7 +3906,7 @@
                   <a:srgbClr val="6B7280"/>
                 </a:solidFill>
               </a:rPr>
-              <a:t>    Basic</a:t>
+              <a:t/>
             </a:r>
           </a:p>
           <a:p>
@@ -3903,7 +3916,7 @@
                   <a:srgbClr val="6B7280"/>
                 </a:solidFill>
               </a:rPr>
-              <a:t>Analyse the DSR — MTD vs target, YoY, anomalies, traffic-light formatting in-grid</a:t>
+              <a:t>Forecast month-end, z-score anomalies, board-ready summary</a:t>
             </a:r>
           </a:p>
         </p:txBody>
@@ -4013,7 +4026,7 @@
                   <a:srgbClr val="1F2937"/>
                 </a:solidFill>
               </a:rPr>
-              <a:t>Researcher · Analyst · Plan in Excel · Image · Pages</a:t>
+              <a:t>Cowork · DSR    Premium</a:t>
             </a:r>
             <a:r>
               <a:rPr sz="900" b="1">
@@ -4031,7 +4044,7 @@
                   <a:srgbClr val="6B7280"/>
                 </a:solidFill>
               </a:rPr>
-              <a:t>Benchmark Jakarta, forecast Q2, simulate +5% conversion, hero visual, share via Pages</a:t>
+              <a:t>Ship a live HTML dashboard with slicers — date, week, channel, anomaly — charts react live</a:t>
             </a:r>
           </a:p>
         </p:txBody>
@@ -4141,7 +4154,7 @@
                   <a:srgbClr val="1F2937"/>
                 </a:solidFill>
               </a:rPr>
-              <a:t>Cowork</a:t>
+              <a:t>Agent Builder    Premium</a:t>
             </a:r>
             <a:r>
               <a:rPr sz="900" b="1">
@@ -4159,7 +4172,7 @@
                   <a:srgbClr val="6B7280"/>
                 </a:solidFill>
               </a:rPr>
-              <a:t>Ship a live HTML dashboard with slicers — date, week, channel, anomaly — charts react live</a:t>
+              <a:t>Build the Store Ops Coach — grounded on DSR, action plan, research</a:t>
             </a:r>
           </a:p>
         </p:txBody>
@@ -4237,7 +4250,7 @@
                   <a:srgbClr val="1F2937"/>
                 </a:solidFill>
               </a:rPr>
-              <a:t>Microsoft 365 Copilot · Basic (Chat, Word, PowerPoint, Excel) + Premium (Researcher, Analyst, Plan in Excel, Image, Pages, Cowork)</a:t>
+              <a:t>Microsoft 365 Copilot · Basic (Chat, Edit with Copilot in W/X/P) + Premium (Researcher, Analyst, Cowork, Agent Builder) · Operations Immersion · 90 minutes</a:t>
             </a:r>
           </a:p>
         </p:txBody>

</xml_diff>

<commit_message>
Edit with Copilot is Premium; remove Basic/Premium badges from storyboard + PPTX
Co-authored-by: Copilot <223556219+Copilot@users.noreply.github.com>
</commit_message>
<xml_diff>
--- a/files/Contoso_Active_Story.pptx
+++ b/files/Contoso_Active_Story.pptx
@@ -3565,7 +3565,7 @@
           <a:p>
             <a:pPr algn="ctr"/>
             <a:r>
-              <a:t>Copilot Chat    Basic</a:t>
+              <a:t>Copilot Chat</a:t>
             </a:r>
           </a:p>
           <a:p>
@@ -3642,7 +3642,7 @@
                   <a:srgbClr val="1F2937"/>
                 </a:solidFill>
               </a:rPr>
-              <a:t>WXP · Edit with Copilot    Basic</a:t>
+              <a:t>WXP Agents · Edit with Copilot</a:t>
             </a:r>
             <a:r>
               <a:rPr sz="900" b="1">
@@ -3770,7 +3770,7 @@
                   <a:srgbClr val="1F2937"/>
                 </a:solidFill>
               </a:rPr>
-              <a:t>Researcher    Premium</a:t>
+              <a:t>Researcher</a:t>
             </a:r>
             <a:r>
               <a:rPr sz="900" b="1">
@@ -3898,7 +3898,7 @@
                   <a:srgbClr val="1F2937"/>
                 </a:solidFill>
               </a:rPr>
-              <a:t>Analyst · DSR    Premium</a:t>
+              <a:t>Analyst · DSR</a:t>
             </a:r>
             <a:r>
               <a:rPr sz="900" b="1">
@@ -4026,7 +4026,7 @@
                   <a:srgbClr val="1F2937"/>
                 </a:solidFill>
               </a:rPr>
-              <a:t>Cowork · DSR    Premium</a:t>
+              <a:t>Cowork · DSR</a:t>
             </a:r>
             <a:r>
               <a:rPr sz="900" b="1">
@@ -4154,7 +4154,7 @@
                   <a:srgbClr val="1F2937"/>
                 </a:solidFill>
               </a:rPr>
-              <a:t>Agent Builder    Premium</a:t>
+              <a:t>Agent Builder</a:t>
             </a:r>
             <a:r>
               <a:rPr sz="900" b="1">
@@ -4250,7 +4250,7 @@
                   <a:srgbClr val="1F2937"/>
                 </a:solidFill>
               </a:rPr>
-              <a:t>Microsoft 365 Copilot · Basic (Chat, Edit with Copilot in W/X/P) + Premium (Researcher, Analyst, Cowork, Agent Builder) · Operations Immersion · 90 minutes</a:t>
+              <a:t>Microsoft 365 Copilot · Chat · Edit with Copilot (W/X/P) · Researcher · Analyst · Cowork · Agent Builder · Operations Immersion · 90 minutes</a:t>
             </a:r>
           </a:p>
         </p:txBody>

</xml_diff>

<commit_message>
Fix step-1 PPTX bug — title was written to ornamental oval instead of the real title TextBox; duplicate text removed
Co-authored-by: Copilot <223556219+Copilot@users.noreply.github.com>
</commit_message>
<xml_diff>
--- a/files/Contoso_Active_Story.pptx
+++ b/files/Contoso_Active_Story.pptx
@@ -3509,7 +3509,7 @@
                   <a:srgbClr val="6B7280"/>
                 </a:solidFill>
               </a:rPr>
-              <a:t>    Basic</a:t>
+              <a:t/>
             </a:r>
           </a:p>
           <a:p>
@@ -3565,7 +3565,7 @@
           <a:p>
             <a:pPr algn="ctr"/>
             <a:r>
-              <a:t>Copilot Chat</a:t>
+              <a:t/>
             </a:r>
           </a:p>
           <a:p>
@@ -3575,7 +3575,7 @@
                   <a:srgbClr val="6B7280"/>
                 </a:solidFill>
               </a:rPr>
-              <a:t>Get the lay of the land — research Q1 sportswear trends, summarise emails &amp; Teams</a:t>
+              <a:t/>
             </a:r>
           </a:p>
         </p:txBody>

</xml_diff>

<commit_message>
Update story date: April 2026 → May 2026 (page headers + PPTX persona block)
Co-authored-by: Copilot <223556219+Copilot@users.noreply.github.com>
</commit_message>
<xml_diff>
--- a/files/Contoso_Active_Story.pptx
+++ b/files/Contoso_Active_Story.pptx
@@ -5,9 +5,9 @@
     <p:sldMasterId id="2147483648" r:id="rId1"/>
   </p:sldMasterIdLst>
   <p:sldIdLst>
-    <p:sldId id="256" r:id="rId7"/>
+    <p:sldId id="256" r:id="rId2"/>
   </p:sldIdLst>
-  <p:sldSz cx="12191695" cy="6858000" type="screen4x3"/>
+  <p:sldSz cx="12192000" cy="6858000"/>
   <p:notesSz cx="6858000" cy="9144000"/>
   <p:defaultTextStyle>
     <a:defPPr>
@@ -104,7 +104,108 @@
       </a:defRPr>
     </a:lvl9pPr>
   </p:defaultTextStyle>
+  <p:extLst>
+    <p:ext uri="{EFAFB233-063F-42B5-8137-9DF3F51BA10A}">
+      <p15:sldGuideLst xmlns:p15="http://schemas.microsoft.com/office/powerpoint/2012/main">
+        <p15:guide id="1" orient="horz" pos="2160">
+          <p15:clr>
+            <a:srgbClr val="A4A3A4"/>
+          </p15:clr>
+        </p15:guide>
+        <p15:guide id="2" pos="2880">
+          <p15:clr>
+            <a:srgbClr val="A4A3A4"/>
+          </p15:clr>
+        </p15:guide>
+      </p15:sldGuideLst>
+    </p:ext>
+  </p:extLst>
 </p:presentation>
+</file>
+
+<file path=ppt/changesInfos/changesInfo1.xml><?xml version="1.0" encoding="utf-8"?>
+<pc:chgInfo xmlns:a="http://schemas.openxmlformats.org/drawingml/2006/main" xmlns:r="http://schemas.openxmlformats.org/officeDocument/2006/relationships" xmlns:ac="http://schemas.microsoft.com/office/drawing/2013/main/command" xmlns:pc="http://schemas.microsoft.com/office/powerpoint/2013/main/command">
+  <pc:docChgLst>
+    <pc:chgData name="Pei Yi Yap" userId="ded5ede2-18a8-43f0-9520-5b9cfae853ea" providerId="ADAL" clId="{48360A01-77E9-4FB0-AFCE-901941CDCF3A}"/>
+    <pc:docChg chg="modSld">
+      <pc:chgData name="Pei Yi Yap" userId="ded5ede2-18a8-43f0-9520-5b9cfae853ea" providerId="ADAL" clId="{48360A01-77E9-4FB0-AFCE-901941CDCF3A}" dt="2026-05-19T13:46:56.961" v="6" actId="404"/>
+      <pc:docMkLst>
+        <pc:docMk/>
+      </pc:docMkLst>
+      <pc:sldChg chg="modSp mod">
+        <pc:chgData name="Pei Yi Yap" userId="ded5ede2-18a8-43f0-9520-5b9cfae853ea" providerId="ADAL" clId="{48360A01-77E9-4FB0-AFCE-901941CDCF3A}" dt="2026-05-19T13:46:56.961" v="6" actId="404"/>
+        <pc:sldMkLst>
+          <pc:docMk/>
+          <pc:sldMk cId="0" sldId="256"/>
+        </pc:sldMkLst>
+        <pc:spChg chg="mod">
+          <ac:chgData name="Pei Yi Yap" userId="ded5ede2-18a8-43f0-9520-5b9cfae853ea" providerId="ADAL" clId="{48360A01-77E9-4FB0-AFCE-901941CDCF3A}" dt="2026-05-19T13:46:43.391" v="2" actId="20577"/>
+          <ac:spMkLst>
+            <pc:docMk/>
+            <pc:sldMk cId="0" sldId="256"/>
+            <ac:spMk id="7" creationId="{00000000-0000-0000-0000-000000000000}"/>
+          </ac:spMkLst>
+        </pc:spChg>
+        <pc:spChg chg="mod">
+          <ac:chgData name="Pei Yi Yap" userId="ded5ede2-18a8-43f0-9520-5b9cfae853ea" providerId="ADAL" clId="{48360A01-77E9-4FB0-AFCE-901941CDCF3A}" dt="2026-05-19T13:46:56.961" v="6" actId="404"/>
+          <ac:spMkLst>
+            <pc:docMk/>
+            <pc:sldMk cId="0" sldId="256"/>
+            <ac:spMk id="10" creationId="{00000000-0000-0000-0000-000000000000}"/>
+          </ac:spMkLst>
+        </pc:spChg>
+        <pc:spChg chg="mod">
+          <ac:chgData name="Pei Yi Yap" userId="ded5ede2-18a8-43f0-9520-5b9cfae853ea" providerId="ADAL" clId="{48360A01-77E9-4FB0-AFCE-901941CDCF3A}" dt="2026-05-19T13:46:56.961" v="6" actId="404"/>
+          <ac:spMkLst>
+            <pc:docMk/>
+            <pc:sldMk cId="0" sldId="256"/>
+            <ac:spMk id="13" creationId="{00000000-0000-0000-0000-000000000000}"/>
+          </ac:spMkLst>
+        </pc:spChg>
+        <pc:spChg chg="mod">
+          <ac:chgData name="Pei Yi Yap" userId="ded5ede2-18a8-43f0-9520-5b9cfae853ea" providerId="ADAL" clId="{48360A01-77E9-4FB0-AFCE-901941CDCF3A}" dt="2026-05-19T13:46:56.961" v="6" actId="404"/>
+          <ac:spMkLst>
+            <pc:docMk/>
+            <pc:sldMk cId="0" sldId="256"/>
+            <ac:spMk id="16" creationId="{00000000-0000-0000-0000-000000000000}"/>
+          </ac:spMkLst>
+        </pc:spChg>
+        <pc:spChg chg="mod">
+          <ac:chgData name="Pei Yi Yap" userId="ded5ede2-18a8-43f0-9520-5b9cfae853ea" providerId="ADAL" clId="{48360A01-77E9-4FB0-AFCE-901941CDCF3A}" dt="2026-05-19T13:46:56.961" v="6" actId="404"/>
+          <ac:spMkLst>
+            <pc:docMk/>
+            <pc:sldMk cId="0" sldId="256"/>
+            <ac:spMk id="19" creationId="{00000000-0000-0000-0000-000000000000}"/>
+          </ac:spMkLst>
+        </pc:spChg>
+        <pc:spChg chg="mod">
+          <ac:chgData name="Pei Yi Yap" userId="ded5ede2-18a8-43f0-9520-5b9cfae853ea" providerId="ADAL" clId="{48360A01-77E9-4FB0-AFCE-901941CDCF3A}" dt="2026-05-19T13:46:56.961" v="6" actId="404"/>
+          <ac:spMkLst>
+            <pc:docMk/>
+            <pc:sldMk cId="0" sldId="256"/>
+            <ac:spMk id="22" creationId="{00000000-0000-0000-0000-000000000000}"/>
+          </ac:spMkLst>
+        </pc:spChg>
+        <pc:spChg chg="mod">
+          <ac:chgData name="Pei Yi Yap" userId="ded5ede2-18a8-43f0-9520-5b9cfae853ea" providerId="ADAL" clId="{48360A01-77E9-4FB0-AFCE-901941CDCF3A}" dt="2026-05-19T13:46:56.961" v="6" actId="404"/>
+          <ac:spMkLst>
+            <pc:docMk/>
+            <pc:sldMk cId="0" sldId="256"/>
+            <ac:spMk id="25" creationId="{00000000-0000-0000-0000-000000000000}"/>
+          </ac:spMkLst>
+        </pc:spChg>
+        <pc:spChg chg="mod">
+          <ac:chgData name="Pei Yi Yap" userId="ded5ede2-18a8-43f0-9520-5b9cfae853ea" providerId="ADAL" clId="{48360A01-77E9-4FB0-AFCE-901941CDCF3A}" dt="2026-05-19T13:46:38.931" v="1" actId="1076"/>
+          <ac:spMkLst>
+            <pc:docMk/>
+            <pc:sldMk cId="0" sldId="256"/>
+            <ac:spMk id="27" creationId="{00000000-0000-0000-0000-000000000000}"/>
+          </ac:spMkLst>
+        </pc:spChg>
+      </pc:sldChg>
+    </pc:docChg>
+  </pc:docChgLst>
+</pc:chgInfo>
 </file>
 
 <file path=ppt/slideLayouts/slideLayout1.xml><?xml version="1.0" encoding="utf-8"?>
@@ -145,10 +246,9 @@
           <a:lstStyle/>
           <a:p>
             <a:r>
-              <a:rPr lang="en-US" smtClean="0"/>
+              <a:rPr lang="en-US"/>
               <a:t>Click to edit Master title style</a:t>
             </a:r>
-            <a:endParaRPr lang="en-US"/>
           </a:p>
         </p:txBody>
       </p:sp>
@@ -264,10 +364,9 @@
           </a:lstStyle>
           <a:p>
             <a:r>
-              <a:rPr lang="en-US" smtClean="0"/>
+              <a:rPr lang="en-US"/>
               <a:t>Click to edit Master subtitle style</a:t>
             </a:r>
-            <a:endParaRPr lang="en-US"/>
           </a:p>
         </p:txBody>
       </p:sp>
@@ -288,7 +387,7 @@
           <a:p>
             <a:fld id="{5BCAD085-E8A6-8845-BD4E-CB4CCA059FC4}" type="datetimeFigureOut">
               <a:rPr lang="en-US" smtClean="0"/>
-              <a:t>1/27/13</a:t>
+              <a:t>19-May-26</a:t>
             </a:fld>
             <a:endParaRPr lang="en-US"/>
           </a:p>
@@ -382,10 +481,9 @@
           <a:lstStyle/>
           <a:p>
             <a:r>
-              <a:rPr lang="en-US" smtClean="0"/>
+              <a:rPr lang="en-US"/>
               <a:t>Click to edit Master title style</a:t>
             </a:r>
-            <a:endParaRPr lang="en-US"/>
           </a:p>
         </p:txBody>
       </p:sp>
@@ -406,38 +504,37 @@
           <a:p>
             <a:pPr lvl="0"/>
             <a:r>
-              <a:rPr lang="en-US" smtClean="0"/>
+              <a:rPr lang="en-US"/>
               <a:t>Click to edit Master text styles</a:t>
             </a:r>
           </a:p>
           <a:p>
             <a:pPr lvl="1"/>
             <a:r>
-              <a:rPr lang="en-US" smtClean="0"/>
+              <a:rPr lang="en-US"/>
               <a:t>Second level</a:t>
             </a:r>
           </a:p>
           <a:p>
             <a:pPr lvl="2"/>
             <a:r>
-              <a:rPr lang="en-US" smtClean="0"/>
+              <a:rPr lang="en-US"/>
               <a:t>Third level</a:t>
             </a:r>
           </a:p>
           <a:p>
             <a:pPr lvl="3"/>
             <a:r>
-              <a:rPr lang="en-US" smtClean="0"/>
+              <a:rPr lang="en-US"/>
               <a:t>Fourth level</a:t>
             </a:r>
           </a:p>
           <a:p>
             <a:pPr lvl="4"/>
             <a:r>
-              <a:rPr lang="en-US" smtClean="0"/>
+              <a:rPr lang="en-US"/>
               <a:t>Fifth level</a:t>
             </a:r>
-            <a:endParaRPr lang="en-US"/>
           </a:p>
         </p:txBody>
       </p:sp>
@@ -458,7 +555,7 @@
           <a:p>
             <a:fld id="{5BCAD085-E8A6-8845-BD4E-CB4CCA059FC4}" type="datetimeFigureOut">
               <a:rPr lang="en-US" smtClean="0"/>
-              <a:t>1/27/13</a:t>
+              <a:t>19-May-26</a:t>
             </a:fld>
             <a:endParaRPr lang="en-US"/>
           </a:p>
@@ -557,10 +654,9 @@
           <a:lstStyle/>
           <a:p>
             <a:r>
-              <a:rPr lang="en-US" smtClean="0"/>
+              <a:rPr lang="en-US"/>
               <a:t>Click to edit Master title style</a:t>
             </a:r>
-            <a:endParaRPr lang="en-US"/>
           </a:p>
         </p:txBody>
       </p:sp>
@@ -586,38 +682,37 @@
           <a:p>
             <a:pPr lvl="0"/>
             <a:r>
-              <a:rPr lang="en-US" smtClean="0"/>
+              <a:rPr lang="en-US"/>
               <a:t>Click to edit Master text styles</a:t>
             </a:r>
           </a:p>
           <a:p>
             <a:pPr lvl="1"/>
             <a:r>
-              <a:rPr lang="en-US" smtClean="0"/>
+              <a:rPr lang="en-US"/>
               <a:t>Second level</a:t>
             </a:r>
           </a:p>
           <a:p>
             <a:pPr lvl="2"/>
             <a:r>
-              <a:rPr lang="en-US" smtClean="0"/>
+              <a:rPr lang="en-US"/>
               <a:t>Third level</a:t>
             </a:r>
           </a:p>
           <a:p>
             <a:pPr lvl="3"/>
             <a:r>
-              <a:rPr lang="en-US" smtClean="0"/>
+              <a:rPr lang="en-US"/>
               <a:t>Fourth level</a:t>
             </a:r>
           </a:p>
           <a:p>
             <a:pPr lvl="4"/>
             <a:r>
-              <a:rPr lang="en-US" smtClean="0"/>
+              <a:rPr lang="en-US"/>
               <a:t>Fifth level</a:t>
             </a:r>
-            <a:endParaRPr lang="en-US"/>
           </a:p>
         </p:txBody>
       </p:sp>
@@ -638,7 +733,7 @@
           <a:p>
             <a:fld id="{5BCAD085-E8A6-8845-BD4E-CB4CCA059FC4}" type="datetimeFigureOut">
               <a:rPr lang="en-US" smtClean="0"/>
-              <a:t>1/27/13</a:t>
+              <a:t>19-May-26</a:t>
             </a:fld>
             <a:endParaRPr lang="en-US"/>
           </a:p>
@@ -732,10 +827,9 @@
           <a:lstStyle/>
           <a:p>
             <a:r>
-              <a:rPr lang="en-US" smtClean="0"/>
+              <a:rPr lang="en-US"/>
               <a:t>Click to edit Master title style</a:t>
             </a:r>
-            <a:endParaRPr lang="en-US"/>
           </a:p>
         </p:txBody>
       </p:sp>
@@ -756,38 +850,37 @@
           <a:p>
             <a:pPr lvl="0"/>
             <a:r>
-              <a:rPr lang="en-US" smtClean="0"/>
+              <a:rPr lang="en-US"/>
               <a:t>Click to edit Master text styles</a:t>
             </a:r>
           </a:p>
           <a:p>
             <a:pPr lvl="1"/>
             <a:r>
-              <a:rPr lang="en-US" smtClean="0"/>
+              <a:rPr lang="en-US"/>
               <a:t>Second level</a:t>
             </a:r>
           </a:p>
           <a:p>
             <a:pPr lvl="2"/>
             <a:r>
-              <a:rPr lang="en-US" smtClean="0"/>
+              <a:rPr lang="en-US"/>
               <a:t>Third level</a:t>
             </a:r>
           </a:p>
           <a:p>
             <a:pPr lvl="3"/>
             <a:r>
-              <a:rPr lang="en-US" smtClean="0"/>
+              <a:rPr lang="en-US"/>
               <a:t>Fourth level</a:t>
             </a:r>
           </a:p>
           <a:p>
             <a:pPr lvl="4"/>
             <a:r>
-              <a:rPr lang="en-US" smtClean="0"/>
+              <a:rPr lang="en-US"/>
               <a:t>Fifth level</a:t>
             </a:r>
-            <a:endParaRPr lang="en-US"/>
           </a:p>
         </p:txBody>
       </p:sp>
@@ -808,7 +901,7 @@
           <a:p>
             <a:fld id="{5BCAD085-E8A6-8845-BD4E-CB4CCA059FC4}" type="datetimeFigureOut">
               <a:rPr lang="en-US" smtClean="0"/>
-              <a:t>1/27/13</a:t>
+              <a:t>19-May-26</a:t>
             </a:fld>
             <a:endParaRPr lang="en-US"/>
           </a:p>
@@ -911,10 +1004,9 @@
           </a:lstStyle>
           <a:p>
             <a:r>
-              <a:rPr lang="en-US" smtClean="0"/>
+              <a:rPr lang="en-US"/>
               <a:t>Click to edit Master title style</a:t>
             </a:r>
-            <a:endParaRPr lang="en-US"/>
           </a:p>
         </p:txBody>
       </p:sp>
@@ -1031,7 +1123,7 @@
           <a:p>
             <a:pPr lvl="0"/>
             <a:r>
-              <a:rPr lang="en-US" smtClean="0"/>
+              <a:rPr lang="en-US"/>
               <a:t>Click to edit Master text styles</a:t>
             </a:r>
           </a:p>
@@ -1054,7 +1146,7 @@
           <a:p>
             <a:fld id="{5BCAD085-E8A6-8845-BD4E-CB4CCA059FC4}" type="datetimeFigureOut">
               <a:rPr lang="en-US" smtClean="0"/>
-              <a:t>1/27/13</a:t>
+              <a:t>19-May-26</a:t>
             </a:fld>
             <a:endParaRPr lang="en-US"/>
           </a:p>
@@ -1148,10 +1240,9 @@
           <a:lstStyle/>
           <a:p>
             <a:r>
-              <a:rPr lang="en-US" smtClean="0"/>
+              <a:rPr lang="en-US"/>
               <a:t>Click to edit Master title style</a:t>
             </a:r>
-            <a:endParaRPr lang="en-US"/>
           </a:p>
         </p:txBody>
       </p:sp>
@@ -1205,38 +1296,37 @@
           <a:p>
             <a:pPr lvl="0"/>
             <a:r>
-              <a:rPr lang="en-US" smtClean="0"/>
+              <a:rPr lang="en-US"/>
               <a:t>Click to edit Master text styles</a:t>
             </a:r>
           </a:p>
           <a:p>
             <a:pPr lvl="1"/>
             <a:r>
-              <a:rPr lang="en-US" smtClean="0"/>
+              <a:rPr lang="en-US"/>
               <a:t>Second level</a:t>
             </a:r>
           </a:p>
           <a:p>
             <a:pPr lvl="2"/>
             <a:r>
-              <a:rPr lang="en-US" smtClean="0"/>
+              <a:rPr lang="en-US"/>
               <a:t>Third level</a:t>
             </a:r>
           </a:p>
           <a:p>
             <a:pPr lvl="3"/>
             <a:r>
-              <a:rPr lang="en-US" smtClean="0"/>
+              <a:rPr lang="en-US"/>
               <a:t>Fourth level</a:t>
             </a:r>
           </a:p>
           <a:p>
             <a:pPr lvl="4"/>
             <a:r>
-              <a:rPr lang="en-US" smtClean="0"/>
+              <a:rPr lang="en-US"/>
               <a:t>Fifth level</a:t>
             </a:r>
-            <a:endParaRPr lang="en-US"/>
           </a:p>
         </p:txBody>
       </p:sp>
@@ -1290,38 +1380,37 @@
           <a:p>
             <a:pPr lvl="0"/>
             <a:r>
-              <a:rPr lang="en-US" smtClean="0"/>
+              <a:rPr lang="en-US"/>
               <a:t>Click to edit Master text styles</a:t>
             </a:r>
           </a:p>
           <a:p>
             <a:pPr lvl="1"/>
             <a:r>
-              <a:rPr lang="en-US" smtClean="0"/>
+              <a:rPr lang="en-US"/>
               <a:t>Second level</a:t>
             </a:r>
           </a:p>
           <a:p>
             <a:pPr lvl="2"/>
             <a:r>
-              <a:rPr lang="en-US" smtClean="0"/>
+              <a:rPr lang="en-US"/>
               <a:t>Third level</a:t>
             </a:r>
           </a:p>
           <a:p>
             <a:pPr lvl="3"/>
             <a:r>
-              <a:rPr lang="en-US" smtClean="0"/>
+              <a:rPr lang="en-US"/>
               <a:t>Fourth level</a:t>
             </a:r>
           </a:p>
           <a:p>
             <a:pPr lvl="4"/>
             <a:r>
-              <a:rPr lang="en-US" smtClean="0"/>
+              <a:rPr lang="en-US"/>
               <a:t>Fifth level</a:t>
             </a:r>
-            <a:endParaRPr lang="en-US"/>
           </a:p>
         </p:txBody>
       </p:sp>
@@ -1342,7 +1431,7 @@
           <a:p>
             <a:fld id="{5BCAD085-E8A6-8845-BD4E-CB4CCA059FC4}" type="datetimeFigureOut">
               <a:rPr lang="en-US" smtClean="0"/>
-              <a:t>1/27/13</a:t>
+              <a:t>19-May-26</a:t>
             </a:fld>
             <a:endParaRPr lang="en-US"/>
           </a:p>
@@ -1440,10 +1529,9 @@
           </a:lstStyle>
           <a:p>
             <a:r>
-              <a:rPr lang="en-US" smtClean="0"/>
+              <a:rPr lang="en-US"/>
               <a:t>Click to edit Master title style</a:t>
             </a:r>
-            <a:endParaRPr lang="en-US"/>
           </a:p>
         </p:txBody>
       </p:sp>
@@ -1506,7 +1594,7 @@
           <a:p>
             <a:pPr lvl="0"/>
             <a:r>
-              <a:rPr lang="en-US" smtClean="0"/>
+              <a:rPr lang="en-US"/>
               <a:t>Click to edit Master text styles</a:t>
             </a:r>
           </a:p>
@@ -1562,38 +1650,37 @@
           <a:p>
             <a:pPr lvl="0"/>
             <a:r>
-              <a:rPr lang="en-US" smtClean="0"/>
+              <a:rPr lang="en-US"/>
               <a:t>Click to edit Master text styles</a:t>
             </a:r>
           </a:p>
           <a:p>
             <a:pPr lvl="1"/>
             <a:r>
-              <a:rPr lang="en-US" smtClean="0"/>
+              <a:rPr lang="en-US"/>
               <a:t>Second level</a:t>
             </a:r>
           </a:p>
           <a:p>
             <a:pPr lvl="2"/>
             <a:r>
-              <a:rPr lang="en-US" smtClean="0"/>
+              <a:rPr lang="en-US"/>
               <a:t>Third level</a:t>
             </a:r>
           </a:p>
           <a:p>
             <a:pPr lvl="3"/>
             <a:r>
-              <a:rPr lang="en-US" smtClean="0"/>
+              <a:rPr lang="en-US"/>
               <a:t>Fourth level</a:t>
             </a:r>
           </a:p>
           <a:p>
             <a:pPr lvl="4"/>
             <a:r>
-              <a:rPr lang="en-US" smtClean="0"/>
+              <a:rPr lang="en-US"/>
               <a:t>Fifth level</a:t>
             </a:r>
-            <a:endParaRPr lang="en-US"/>
           </a:p>
         </p:txBody>
       </p:sp>
@@ -1656,7 +1743,7 @@
           <a:p>
             <a:pPr lvl="0"/>
             <a:r>
-              <a:rPr lang="en-US" smtClean="0"/>
+              <a:rPr lang="en-US"/>
               <a:t>Click to edit Master text styles</a:t>
             </a:r>
           </a:p>
@@ -1712,38 +1799,37 @@
           <a:p>
             <a:pPr lvl="0"/>
             <a:r>
-              <a:rPr lang="en-US" smtClean="0"/>
+              <a:rPr lang="en-US"/>
               <a:t>Click to edit Master text styles</a:t>
             </a:r>
           </a:p>
           <a:p>
             <a:pPr lvl="1"/>
             <a:r>
-              <a:rPr lang="en-US" smtClean="0"/>
+              <a:rPr lang="en-US"/>
               <a:t>Second level</a:t>
             </a:r>
           </a:p>
           <a:p>
             <a:pPr lvl="2"/>
             <a:r>
-              <a:rPr lang="en-US" smtClean="0"/>
+              <a:rPr lang="en-US"/>
               <a:t>Third level</a:t>
             </a:r>
           </a:p>
           <a:p>
             <a:pPr lvl="3"/>
             <a:r>
-              <a:rPr lang="en-US" smtClean="0"/>
+              <a:rPr lang="en-US"/>
               <a:t>Fourth level</a:t>
             </a:r>
           </a:p>
           <a:p>
             <a:pPr lvl="4"/>
             <a:r>
-              <a:rPr lang="en-US" smtClean="0"/>
+              <a:rPr lang="en-US"/>
               <a:t>Fifth level</a:t>
             </a:r>
-            <a:endParaRPr lang="en-US"/>
           </a:p>
         </p:txBody>
       </p:sp>
@@ -1764,7 +1850,7 @@
           <a:p>
             <a:fld id="{5BCAD085-E8A6-8845-BD4E-CB4CCA059FC4}" type="datetimeFigureOut">
               <a:rPr lang="en-US" smtClean="0"/>
-              <a:t>1/27/13</a:t>
+              <a:t>19-May-26</a:t>
             </a:fld>
             <a:endParaRPr lang="en-US"/>
           </a:p>
@@ -1858,10 +1944,9 @@
           <a:lstStyle/>
           <a:p>
             <a:r>
-              <a:rPr lang="en-US" smtClean="0"/>
+              <a:rPr lang="en-US"/>
               <a:t>Click to edit Master title style</a:t>
             </a:r>
-            <a:endParaRPr lang="en-US"/>
           </a:p>
         </p:txBody>
       </p:sp>
@@ -1882,7 +1967,7 @@
           <a:p>
             <a:fld id="{5BCAD085-E8A6-8845-BD4E-CB4CCA059FC4}" type="datetimeFigureOut">
               <a:rPr lang="en-US" smtClean="0"/>
-              <a:t>1/27/13</a:t>
+              <a:t>19-May-26</a:t>
             </a:fld>
             <a:endParaRPr lang="en-US"/>
           </a:p>
@@ -1977,7 +2062,7 @@
           <a:p>
             <a:fld id="{5BCAD085-E8A6-8845-BD4E-CB4CCA059FC4}" type="datetimeFigureOut">
               <a:rPr lang="en-US" smtClean="0"/>
-              <a:t>1/27/13</a:t>
+              <a:t>19-May-26</a:t>
             </a:fld>
             <a:endParaRPr lang="en-US"/>
           </a:p>
@@ -2080,10 +2165,9 @@
           </a:lstStyle>
           <a:p>
             <a:r>
-              <a:rPr lang="en-US" smtClean="0"/>
+              <a:rPr lang="en-US"/>
               <a:t>Click to edit Master title style</a:t>
             </a:r>
-            <a:endParaRPr lang="en-US"/>
           </a:p>
         </p:txBody>
       </p:sp>
@@ -2137,38 +2221,37 @@
           <a:p>
             <a:pPr lvl="0"/>
             <a:r>
-              <a:rPr lang="en-US" smtClean="0"/>
+              <a:rPr lang="en-US"/>
               <a:t>Click to edit Master text styles</a:t>
             </a:r>
           </a:p>
           <a:p>
             <a:pPr lvl="1"/>
             <a:r>
-              <a:rPr lang="en-US" smtClean="0"/>
+              <a:rPr lang="en-US"/>
               <a:t>Second level</a:t>
             </a:r>
           </a:p>
           <a:p>
             <a:pPr lvl="2"/>
             <a:r>
-              <a:rPr lang="en-US" smtClean="0"/>
+              <a:rPr lang="en-US"/>
               <a:t>Third level</a:t>
             </a:r>
           </a:p>
           <a:p>
             <a:pPr lvl="3"/>
             <a:r>
-              <a:rPr lang="en-US" smtClean="0"/>
+              <a:rPr lang="en-US"/>
               <a:t>Fourth level</a:t>
             </a:r>
           </a:p>
           <a:p>
             <a:pPr lvl="4"/>
             <a:r>
-              <a:rPr lang="en-US" smtClean="0"/>
+              <a:rPr lang="en-US"/>
               <a:t>Fifth level</a:t>
             </a:r>
-            <a:endParaRPr lang="en-US"/>
           </a:p>
         </p:txBody>
       </p:sp>
@@ -2231,7 +2314,7 @@
           <a:p>
             <a:pPr lvl="0"/>
             <a:r>
-              <a:rPr lang="en-US" smtClean="0"/>
+              <a:rPr lang="en-US"/>
               <a:t>Click to edit Master text styles</a:t>
             </a:r>
           </a:p>
@@ -2254,7 +2337,7 @@
           <a:p>
             <a:fld id="{5BCAD085-E8A6-8845-BD4E-CB4CCA059FC4}" type="datetimeFigureOut">
               <a:rPr lang="en-US" smtClean="0"/>
-              <a:t>1/27/13</a:t>
+              <a:t>19-May-26</a:t>
             </a:fld>
             <a:endParaRPr lang="en-US"/>
           </a:p>
@@ -2357,10 +2440,9 @@
           </a:lstStyle>
           <a:p>
             <a:r>
-              <a:rPr lang="en-US" smtClean="0"/>
+              <a:rPr lang="en-US"/>
               <a:t>Click to edit Master title style</a:t>
             </a:r>
-            <a:endParaRPr lang="en-US"/>
           </a:p>
         </p:txBody>
       </p:sp>
@@ -2484,7 +2566,7 @@
           <a:p>
             <a:pPr lvl="0"/>
             <a:r>
-              <a:rPr lang="en-US" smtClean="0"/>
+              <a:rPr lang="en-US"/>
               <a:t>Click to edit Master text styles</a:t>
             </a:r>
           </a:p>
@@ -2507,7 +2589,7 @@
           <a:p>
             <a:fld id="{5BCAD085-E8A6-8845-BD4E-CB4CCA059FC4}" type="datetimeFigureOut">
               <a:rPr lang="en-US" smtClean="0"/>
-              <a:t>1/27/13</a:t>
+              <a:t>19-May-26</a:t>
             </a:fld>
             <a:endParaRPr lang="en-US"/>
           </a:p>
@@ -2616,10 +2698,9 @@
           <a:lstStyle/>
           <a:p>
             <a:r>
-              <a:rPr lang="en-US" smtClean="0"/>
+              <a:rPr lang="en-US"/>
               <a:t>Click to edit Master title style</a:t>
             </a:r>
-            <a:endParaRPr lang="en-US"/>
           </a:p>
         </p:txBody>
       </p:sp>
@@ -2650,38 +2731,37 @@
           <a:p>
             <a:pPr lvl="0"/>
             <a:r>
-              <a:rPr lang="en-US" smtClean="0"/>
+              <a:rPr lang="en-US"/>
               <a:t>Click to edit Master text styles</a:t>
             </a:r>
           </a:p>
           <a:p>
             <a:pPr lvl="1"/>
             <a:r>
-              <a:rPr lang="en-US" smtClean="0"/>
+              <a:rPr lang="en-US"/>
               <a:t>Second level</a:t>
             </a:r>
           </a:p>
           <a:p>
             <a:pPr lvl="2"/>
             <a:r>
-              <a:rPr lang="en-US" smtClean="0"/>
+              <a:rPr lang="en-US"/>
               <a:t>Third level</a:t>
             </a:r>
           </a:p>
           <a:p>
             <a:pPr lvl="3"/>
             <a:r>
-              <a:rPr lang="en-US" smtClean="0"/>
+              <a:rPr lang="en-US"/>
               <a:t>Fourth level</a:t>
             </a:r>
           </a:p>
           <a:p>
             <a:pPr lvl="4"/>
             <a:r>
-              <a:rPr lang="en-US" smtClean="0"/>
+              <a:rPr lang="en-US"/>
               <a:t>Fifth level</a:t>
             </a:r>
-            <a:endParaRPr lang="en-US"/>
           </a:p>
         </p:txBody>
       </p:sp>
@@ -2720,7 +2800,7 @@
           <a:p>
             <a:fld id="{5BCAD085-E8A6-8845-BD4E-CB4CCA059FC4}" type="datetimeFigureOut">
               <a:rPr lang="en-US" smtClean="0"/>
-              <a:t>1/27/13</a:t>
+              <a:t>19-May-26</a:t>
             </a:fld>
             <a:endParaRPr lang="en-US"/>
           </a:p>
@@ -3079,7 +3159,7 @@
 </file>
 
 <file path=ppt/slides/slide1.xml><?xml version="1.0" encoding="utf-8"?>
-<p:sld xmlns:a="http://schemas.openxmlformats.org/drawingml/2006/main" xmlns:p="http://schemas.openxmlformats.org/presentationml/2006/main" xmlns:r="http://schemas.openxmlformats.org/officeDocument/2006/relationships">
+<p:sld xmlns:a="http://schemas.openxmlformats.org/drawingml/2006/main" xmlns:r="http://schemas.openxmlformats.org/officeDocument/2006/relationships" xmlns:p="http://schemas.openxmlformats.org/presentationml/2006/main">
   <p:cSld>
     <p:spTree>
       <p:nvGrpSpPr>
@@ -3087,7 +3167,14 @@
         <p:cNvGrpSpPr/>
         <p:nvPr/>
       </p:nvGrpSpPr>
-      <p:grpSpPr/>
+      <p:grpSpPr>
+        <a:xfrm>
+          <a:off x="0" y="0"/>
+          <a:ext cx="0" cy="0"/>
+          <a:chOff x="0" y="0"/>
+          <a:chExt cx="0" cy="0"/>
+        </a:xfrm>
+      </p:grpSpPr>
       <p:sp>
         <p:nvSpPr>
           <p:cNvPr id="2" name="Rectangle 1"/>
@@ -3128,6 +3215,7 @@
           <a:lstStyle/>
           <a:p>
             <a:pPr algn="ctr"/>
+            <a:endParaRPr/>
           </a:p>
         </p:txBody>
       </p:sp>
@@ -3171,6 +3259,7 @@
           <a:lstStyle/>
           <a:p>
             <a:pPr algn="ctr"/>
+            <a:endParaRPr/>
           </a:p>
         </p:txBody>
       </p:sp>
@@ -3214,6 +3303,7 @@
           <a:lstStyle/>
           <a:p>
             <a:pPr algn="ctr"/>
+            <a:endParaRPr/>
           </a:p>
         </p:txBody>
       </p:sp>
@@ -3348,7 +3438,7 @@
                   <a:srgbClr val="FFFFFF"/>
                 </a:solidFill>
               </a:rPr>
-              <a:t>It's 1 April 2026.</a:t>
+              <a:t>It's 1 May 2026.</a:t>
             </a:r>
           </a:p>
           <a:p>
@@ -3372,7 +3462,7 @@
         <p:spPr>
           <a:xfrm>
             <a:off x="4572000" y="548640"/>
-            <a:ext cx="7223760" cy="548640"/>
+            <a:ext cx="2346604" cy="400110"/>
           </a:xfrm>
           <a:prstGeom prst="rect">
             <a:avLst/>
@@ -3386,12 +3476,12 @@
           <a:lstStyle/>
           <a:p>
             <a:r>
-              <a:rPr sz="2000" b="1">
+              <a:rPr sz="2000" b="1" dirty="0">
                 <a:solidFill>
                   <a:srgbClr val="1F2937"/>
                 </a:solidFill>
               </a:rPr>
-              <a:t>The 90-minute Operations flow</a:t>
+              <a:t>The Operations flow</a:t>
             </a:r>
           </a:p>
         </p:txBody>
@@ -3436,6 +3526,7 @@
           <a:lstStyle/>
           <a:p>
             <a:pPr algn="ctr"/>
+            <a:endParaRPr/>
           </a:p>
         </p:txBody>
       </p:sp>
@@ -3482,7 +3573,7 @@
         <p:spPr>
           <a:xfrm>
             <a:off x="5349240" y="1216152"/>
-            <a:ext cx="6035040" cy="685800"/>
+            <a:ext cx="6035040" cy="553998"/>
           </a:xfrm>
           <a:prstGeom prst="rect">
             <a:avLst/>
@@ -3496,30 +3587,38 @@
           <a:lstStyle/>
           <a:p>
             <a:r>
-              <a:rPr sz="1400" b="1">
+              <a:rPr b="1" dirty="0">
                 <a:solidFill>
                   <a:srgbClr val="1F2937"/>
                 </a:solidFill>
               </a:rPr>
               <a:t>Copilot Chat</a:t>
             </a:r>
-            <a:r>
-              <a:rPr sz="900" b="1">
+          </a:p>
+          <a:p>
+            <a:r>
+              <a:rPr sz="1200" dirty="0">
                 <a:solidFill>
                   <a:srgbClr val="6B7280"/>
                 </a:solidFill>
               </a:rPr>
-              <a:t/>
-            </a:r>
-          </a:p>
-          <a:p>
-            <a:r>
-              <a:rPr sz="1050">
+              <a:t>Get the lay of the land — research Q1 sportswear trends, </a:t>
+            </a:r>
+            <a:r>
+              <a:rPr sz="1200" dirty="0" err="1">
                 <a:solidFill>
                   <a:srgbClr val="6B7280"/>
                 </a:solidFill>
               </a:rPr>
-              <a:t>Get the lay of the land — research Q1 sportswear trends, summarise emails &amp; Teams</a:t>
+              <a:t>summarise</a:t>
+            </a:r>
+            <a:r>
+              <a:rPr sz="1200" dirty="0">
+                <a:solidFill>
+                  <a:srgbClr val="6B7280"/>
+                </a:solidFill>
+              </a:rPr>
+              <a:t> emails &amp; Teams</a:t>
             </a:r>
           </a:p>
         </p:txBody>
@@ -3564,19 +3663,10 @@
           <a:lstStyle/>
           <a:p>
             <a:pPr algn="ctr"/>
-            <a:r>
-              <a:t/>
-            </a:r>
-          </a:p>
-          <a:p>
-            <a:r>
-              <a:rPr sz="1050">
-                <a:solidFill>
-                  <a:srgbClr val="6B7280"/>
-                </a:solidFill>
-              </a:rPr>
-              <a:t/>
-            </a:r>
+            <a:endParaRPr/>
+          </a:p>
+          <a:p>
+            <a:endParaRPr/>
           </a:p>
         </p:txBody>
       </p:sp>
@@ -3623,7 +3713,7 @@
         <p:spPr>
           <a:xfrm>
             <a:off x="5349240" y="1993392"/>
-            <a:ext cx="6035040" cy="685800"/>
+            <a:ext cx="6035040" cy="553998"/>
           </a:xfrm>
           <a:prstGeom prst="rect">
             <a:avLst/>
@@ -3637,25 +3727,17 @@
           <a:lstStyle/>
           <a:p>
             <a:r>
-              <a:rPr sz="1400" b="1">
+              <a:rPr b="1">
                 <a:solidFill>
                   <a:srgbClr val="1F2937"/>
                 </a:solidFill>
               </a:rPr>
               <a:t>WXP Agents · Edit with Copilot</a:t>
             </a:r>
-            <a:r>
-              <a:rPr sz="900" b="1">
-                <a:solidFill>
-                  <a:srgbClr val="6B7280"/>
-                </a:solidFill>
-              </a:rPr>
-              <a:t/>
-            </a:r>
-          </a:p>
-          <a:p>
-            <a:r>
-              <a:rPr sz="1050">
+          </a:p>
+          <a:p>
+            <a:r>
+              <a:rPr sz="1200">
                 <a:solidFill>
                   <a:srgbClr val="6B7280"/>
                 </a:solidFill>
@@ -3705,6 +3787,7 @@
           <a:lstStyle/>
           <a:p>
             <a:pPr algn="ctr"/>
+            <a:endParaRPr/>
           </a:p>
         </p:txBody>
       </p:sp>
@@ -3751,7 +3834,7 @@
         <p:spPr>
           <a:xfrm>
             <a:off x="5349240" y="2770632"/>
-            <a:ext cx="6035040" cy="685800"/>
+            <a:ext cx="6035040" cy="553998"/>
           </a:xfrm>
           <a:prstGeom prst="rect">
             <a:avLst/>
@@ -3765,25 +3848,17 @@
           <a:lstStyle/>
           <a:p>
             <a:r>
-              <a:rPr sz="1400" b="1">
+              <a:rPr b="1">
                 <a:solidFill>
                   <a:srgbClr val="1F2937"/>
                 </a:solidFill>
               </a:rPr>
               <a:t>Researcher</a:t>
             </a:r>
-            <a:r>
-              <a:rPr sz="900" b="1">
-                <a:solidFill>
-                  <a:srgbClr val="6B7280"/>
-                </a:solidFill>
-              </a:rPr>
-              <a:t/>
-            </a:r>
-          </a:p>
-          <a:p>
-            <a:r>
-              <a:rPr sz="1050">
+          </a:p>
+          <a:p>
+            <a:r>
+              <a:rPr sz="1200">
                 <a:solidFill>
                   <a:srgbClr val="6B7280"/>
                 </a:solidFill>
@@ -3833,6 +3908,7 @@
           <a:lstStyle/>
           <a:p>
             <a:pPr algn="ctr"/>
+            <a:endParaRPr/>
           </a:p>
         </p:txBody>
       </p:sp>
@@ -3879,7 +3955,7 @@
         <p:spPr>
           <a:xfrm>
             <a:off x="5349240" y="3547872"/>
-            <a:ext cx="6035040" cy="685800"/>
+            <a:ext cx="6035040" cy="553998"/>
           </a:xfrm>
           <a:prstGeom prst="rect">
             <a:avLst/>
@@ -3893,25 +3969,17 @@
           <a:lstStyle/>
           <a:p>
             <a:r>
-              <a:rPr sz="1400" b="1">
+              <a:rPr b="1">
                 <a:solidFill>
                   <a:srgbClr val="1F2937"/>
                 </a:solidFill>
               </a:rPr>
               <a:t>Analyst · DSR</a:t>
             </a:r>
-            <a:r>
-              <a:rPr sz="900" b="1">
-                <a:solidFill>
-                  <a:srgbClr val="6B7280"/>
-                </a:solidFill>
-              </a:rPr>
-              <a:t/>
-            </a:r>
-          </a:p>
-          <a:p>
-            <a:r>
-              <a:rPr sz="1050">
+          </a:p>
+          <a:p>
+            <a:r>
+              <a:rPr sz="1200">
                 <a:solidFill>
                   <a:srgbClr val="6B7280"/>
                 </a:solidFill>
@@ -3961,6 +4029,7 @@
           <a:lstStyle/>
           <a:p>
             <a:pPr algn="ctr"/>
+            <a:endParaRPr/>
           </a:p>
         </p:txBody>
       </p:sp>
@@ -4007,7 +4076,7 @@
         <p:spPr>
           <a:xfrm>
             <a:off x="5349240" y="4325112"/>
-            <a:ext cx="6035040" cy="685800"/>
+            <a:ext cx="6035040" cy="553998"/>
           </a:xfrm>
           <a:prstGeom prst="rect">
             <a:avLst/>
@@ -4021,25 +4090,25 @@
           <a:lstStyle/>
           <a:p>
             <a:r>
-              <a:rPr sz="1400" b="1">
+              <a:rPr b="1" dirty="0" err="1">
                 <a:solidFill>
                   <a:srgbClr val="1F2937"/>
                 </a:solidFill>
               </a:rPr>
-              <a:t>Cowork · DSR</a:t>
-            </a:r>
-            <a:r>
-              <a:rPr sz="900" b="1">
-                <a:solidFill>
-                  <a:srgbClr val="E25522"/>
+              <a:t>Cowork</a:t>
+            </a:r>
+            <a:r>
+              <a:rPr b="1" dirty="0">
+                <a:solidFill>
+                  <a:srgbClr val="1F2937"/>
                 </a:solidFill>
               </a:rPr>
-              <a:t/>
-            </a:r>
-          </a:p>
-          <a:p>
-            <a:r>
-              <a:rPr sz="1050">
+              <a:t> · DSR</a:t>
+            </a:r>
+          </a:p>
+          <a:p>
+            <a:r>
+              <a:rPr sz="1200">
                 <a:solidFill>
                   <a:srgbClr val="6B7280"/>
                 </a:solidFill>
@@ -4089,6 +4158,7 @@
           <a:lstStyle/>
           <a:p>
             <a:pPr algn="ctr"/>
+            <a:endParaRPr/>
           </a:p>
         </p:txBody>
       </p:sp>
@@ -4135,7 +4205,7 @@
         <p:spPr>
           <a:xfrm>
             <a:off x="5349240" y="5102352"/>
-            <a:ext cx="6035040" cy="685800"/>
+            <a:ext cx="6035040" cy="553998"/>
           </a:xfrm>
           <a:prstGeom prst="rect">
             <a:avLst/>
@@ -4149,25 +4219,17 @@
           <a:lstStyle/>
           <a:p>
             <a:r>
-              <a:rPr sz="1400" b="1">
+              <a:rPr b="1">
                 <a:solidFill>
                   <a:srgbClr val="1F2937"/>
                 </a:solidFill>
               </a:rPr>
               <a:t>Agent Builder</a:t>
             </a:r>
-            <a:r>
-              <a:rPr sz="900" b="1">
-                <a:solidFill>
-                  <a:srgbClr val="E25522"/>
-                </a:solidFill>
-              </a:rPr>
-              <a:t/>
-            </a:r>
-          </a:p>
-          <a:p>
-            <a:r>
-              <a:rPr sz="1050">
+          </a:p>
+          <a:p>
+            <a:r>
+              <a:rPr sz="1200">
                 <a:solidFill>
                   <a:srgbClr val="6B7280"/>
                 </a:solidFill>
@@ -4219,6 +4281,7 @@
           <a:lstStyle/>
           <a:p>
             <a:pPr algn="ctr"/>
+            <a:endParaRPr/>
           </a:p>
         </p:txBody>
       </p:sp>
@@ -4230,8 +4293,8 @@
         </p:nvSpPr>
         <p:spPr>
           <a:xfrm>
-            <a:off x="4709160" y="6263640"/>
-            <a:ext cx="7040880" cy="320040"/>
+            <a:off x="5374457" y="6311329"/>
+            <a:ext cx="5618846" cy="246221"/>
           </a:xfrm>
           <a:prstGeom prst="rect">
             <a:avLst/>
@@ -4245,12 +4308,28 @@
           <a:lstStyle/>
           <a:p>
             <a:r>
-              <a:rPr sz="1000" b="1">
+              <a:rPr sz="1000" b="1" dirty="0">
                 <a:solidFill>
                   <a:srgbClr val="1F2937"/>
                 </a:solidFill>
               </a:rPr>
-              <a:t>Microsoft 365 Copilot · Chat · Edit with Copilot (W/X/P) · Researcher · Analyst · Cowork · Agent Builder · Operations Immersion · 90 minutes</a:t>
+              <a:t>Microsoft 365 Copilot · Chat · Edit with Copilot (W/X/P) · Researcher · Analyst · </a:t>
+            </a:r>
+            <a:r>
+              <a:rPr sz="1000" b="1" dirty="0" err="1">
+                <a:solidFill>
+                  <a:srgbClr val="1F2937"/>
+                </a:solidFill>
+              </a:rPr>
+              <a:t>Cowork</a:t>
+            </a:r>
+            <a:r>
+              <a:rPr sz="1000" b="1" dirty="0">
+                <a:solidFill>
+                  <a:srgbClr val="1F2937"/>
+                </a:solidFill>
+              </a:rPr>
+              <a:t> · Agent Builder</a:t>
             </a:r>
           </a:p>
         </p:txBody>
@@ -4581,4 +4660,10 @@
   </a:objectDefaults>
   <a:extraClrSchemeLst/>
 </a:theme>
+</file>
+
+<file path=docMetadata/LabelInfo.xml><?xml version="1.0" encoding="utf-8"?>
+<clbl:labelList xmlns:clbl="http://schemas.microsoft.com/office/2020/mipLabelMetadata">
+  <clbl:label id="{f42aa342-8706-4288-bd11-ebb85995028c}" enabled="1" method="Standard" siteId="{72f988bf-86f1-41af-91ab-2d7cd011db47}" removed="0"/>
+</clbl:labelList>
 </file>
</xml_diff>